<commit_message>
Update notebook to E_sPAR naming
</commit_message>
<xml_diff>
--- a/prototyping/E_sPAR_schematic.pptx
+++ b/prototyping/E_sPAR_schematic.pptx
@@ -899,7 +899,7 @@
                 <a:ea typeface="Calibri" pitchFamily="34" charset="-122"/>
                 <a:cs typeface="Calibri" pitchFamily="34" charset="-120"/>
               </a:rPr>
-              <a:t>E_d</a:t>
+              <a:t>E_s</a:t>
             </a:r>
             <a:r>
               <a:rPr lang="en-US" sz="2200" b="1" dirty="0">
@@ -949,7 +949,7 @@
                 <a:ea typeface="Calibri" pitchFamily="34" charset="-122"/>
                 <a:cs typeface="Calibri" pitchFamily="34" charset="-120"/>
               </a:rPr>
-              <a:t>Land station reference sensor: top-down view on a prototyping breadboard</a:t>
+              <a:t>Surface reference sensor: top-down view on a prototyping breadboard</a:t>
             </a:r>
             <a:endParaRPr lang="en-US" sz="1200" dirty="0"/>
           </a:p>
@@ -6291,7 +6291,7 @@
                 <a:ea typeface="Calibri" pitchFamily="34" charset="-122"/>
                 <a:cs typeface="Calibri" pitchFamily="34" charset="-120"/>
               </a:rPr>
-              <a:t>E_d</a:t>
+              <a:t>E_s</a:t>
             </a:r>
             <a:r>
               <a:rPr lang="en-US" sz="2200" b="1" dirty="0">

</xml_diff>